<commit_message>
Add 45-minute French speech script and jury Q&A; speaker notes of the deck from the same source
Co-Authored-By: Claude Opus 5.5 <noreply@anthropic.com>
Claude-Session: https://claude.ai/code/session_0173yS86XsftnFiWfnaT9Pqj
</commit_message>
<xml_diff>
--- a/defense/Belhadj_PhD_Defence.pptx
+++ b/defense/Belhadj_PhD_Defence.pptx
@@ -1763,7 +1763,7 @@
           <a:p>
             <a:r>
               <a:rPr lang="en-US" dirty="0"/>
-              <a:t>[0:00 – 0:45] Bonjour. Je remercie les membres du jury. Je vais présenter ma thèse intitulée « Deep Learning-Based Prediction of Disease Severity Using Medical Imaging: An Application to Diabetology ». En une phrase : la thèse étudie comment trois types d'information – les relations entre images, la topologie des vaisseaux rétiniens et l'ordre des grades – peuvent améliorer le classement automatique de la rétinopathie diabétique. Les trois cercles R, S, O sur cette diapositive reviendront tout au long de la présentation : R pour Relationnel, S pour Structurel (topologie), O pour Ordinal.</a:t>
+              <a:t>[00:00 – 01:00]  Monsieur le Président, Mesdames et Messieurs les membres du jury, bonjour. Je vous remercie d'avoir accepté d'évaluer ce travail. Je vais vous présenter ma thèse intitulée « Deep Learning-Based Prediction of Disease Severity Using Medical Imaging: An Application to Diabetology ». En une phrase : cette thèse étudie comment trois types d'information – les relations entre les images, la topologie des vaisseaux de la rétine et l'ordre des grades de la maladie – peuvent améliorer le classement automatique de la rétinopathie diabétique. Les trois cercles R, S et O que vous voyez reviendront tout au long de la présentation : R pour relationnel, S pour structurel, c'est-à-dire la topologie, et O pour ordinal.</a:t>
             </a:r>
             <a:endParaRPr lang="en-US" dirty="0"/>
           </a:p>
@@ -1851,7 +1851,7 @@
           <a:p>
             <a:r>
               <a:rPr lang="en-US" dirty="0"/>
-              <a:t>[9:15 – 10:45] Choix méthodologique essentiel : la thèse propose un cadre de recherche à trois axes, pas un modèle unique. Chaque axe est porté par un système dédié, pour mesurer sa contribution séparément. TOPORET teste relations et topologie vasculaire (H1, H2), en mode transductif. DGTS reprend ces deux ingrédients en mode inductif, avec un régulariseur topologique dans l'espace des caractéristiques, et l'évalue sur EyePACS. DOTS ajoute l'ordinalité et est testé contre les objectifs de sécurité (H3), sur Messidor-2. Les trois systèmes ne fournissent donc pas la même forme de preuve – et je le dis explicitement. Tous les jeux de données sont publics et les graines fixées.</a:t>
+              <a:t>[09:30 – 11:00]  Un choix méthodologique essentiel : la thèse propose un cadre de recherche à trois axes, et non un modèle unique. Chaque axe est porté par un système dédié, pour pouvoir mesurer sa contribution séparément, avec sa propre ablation. TOPORET teste ensemble les relations et la topologie des vaisseaux, sur trois bases publiques, selon un protocole transductif ; il porte H1 et H2. DGTS reprend ces deux ingrédients dans un graphe inductif, avec un régulariseur topologique dans l'espace des caractéristiques, et il est évalué sans réentraînement sur EyePACS. DOTS ajoute l'ordinalité et est évalué contre les objectifs de sécurité sur Messidor-2 ; il porte H3. Ces trois systèmes ne fournissent donc pas la même forme de preuve, et je le dis explicitement : preuve transductive pour TOPORET, preuve inductive et externe pour DGTS, preuve orientée dépistage, en estimation ponctuelle, pour DOTS.</a:t>
             </a:r>
             <a:endParaRPr lang="en-US" dirty="0"/>
           </a:p>
@@ -1939,7 +1939,7 @@
           <a:p>
             <a:r>
               <a:rPr lang="en-US" dirty="0"/>
-              <a:t>[10:45 – 11:30] Tous les systèmes reposent sur une chaîne en six étapes à interfaces typées : prétraitement et squelette vasculaire, backbone CNN, homologie persistante, fusion, graphe de population, puis tête de classement. Chaque étape appartient à un axe (couleurs). Les interfaces typées permettent de tester chaque étape séparément, ce que j'exploite au chapitre 6 pour la vérification logicielle.</a:t>
+              <a:t>[11:00 – 12:00]  Tous les systèmes reposent sur une chaîne en six étapes, avec des interfaces typées : le prétraitement et l'extraction du squelette vasculaire, un réseau de convolution, le calcul de l'homologie persistante, la fusion des caractéristiques, le graphe de population, et enfin la tête de classement. Les couleurs indiquent l'axe auquel appartient chaque étape. Ces interfaces typées permettent de tester chaque étape séparément ; je m'en sers au chapitre 6 pour la vérification logicielle.</a:t>
             </a:r>
             <a:endParaRPr lang="en-US" dirty="0"/>
           </a:p>
@@ -2027,7 +2027,7 @@
           <a:p>
             <a:r>
               <a:rPr lang="en-US" dirty="0"/>
-              <a:t>[11:30] Troisième partie : les trois outils, puis les premiers résultats qui ont motivé TOPORET.</a:t>
+              <a:t>[12:00 – 12:15]  Troisième partie : les trois outils, puis les premiers résultats qui ont conduit à TOPORET.</a:t>
             </a:r>
             <a:endParaRPr lang="en-US" dirty="0"/>
           </a:p>
@@ -2115,7 +2115,7 @@
           <a:p>
             <a:r>
               <a:rPr lang="en-US" dirty="0"/>
-              <a:t>[11:45 – 13:45] Trois outils, expliqués simplement. (1) Graphe de population et GraphSAGE : chaque image est un nœud ; on relie les images qui se ressemblent ; le réseau agrège l'information des voisins – l'idée est qu'un cas ressemble à ses voisins. (2) Homologie persistante : on regarde le squelette des vaisseaux comme un nuage de points et on fait grossir des boules autour de chaque point ; on compte les composantes (H0) et les boucles (H1) qui apparaissent et disparaissent. Les boucles qui persistent longtemps sont les vraies structures, les autres sont du bruit. (3) CORAL : au lieu de prédire 5 classes sans ordre, on répond à 4 questions binaires emboîtées « le grade est-il ≥ 1 ? ≥ 2 ? ≥ 3 ? ≥ 4 ? », ce qui respecte l'ordre des grades.</a:t>
+              <a:t>[12:15 – 14:00]  Trois outils, expliqués simplement. Le premier est le graphe de population, traité par GraphSAGE. Chaque image est un nœud ; on relie les images qui se ressemblent ; puis le réseau agrège, pour chaque nœud, l'information de ses voisins. L'idée est qu'un cas ressemble souvent à ses voisins. Le deuxième est l'homologie persistante. On considère le squelette des vaisseaux comme un nuage de points, et l'on fait grossir progressivement une boule autour de chaque point. À chaque échelle, on compte les composantes connexes, notées H0, et les boucles, notées H1. Une boucle qui persiste sur une large gamme d'échelles est une vraie structure ; une boucle qui disparaît aussitôt est du bruit. Le troisième est la régression ordinale CORAL. Au lieu de choisir parmi cinq classes sans ordre, le modèle répond à quatre questions binaires emboîtées : le grade est-il au moins 1, au moins 2, au moins 3, au moins 4 ? L'ordre des grades est ainsi inscrit dans le modèle.</a:t>
             </a:r>
             <a:endParaRPr lang="en-US" dirty="0"/>
           </a:p>
@@ -2203,7 +2203,7 @@
           <a:p>
             <a:r>
               <a:rPr lang="en-US" dirty="0"/>
-              <a:t>[13:45 – 15:30] Avant de construire TOPORET, j'ai accumulé des indices. F1 : le gabarit de graphe a d'abord été testé hors médecine – orchestration de microservices et détection d'anomalies – avec un F1 de 94,4 à 97,0 % dans l'étude de conférence. Mais la réévaluation sur dix exécutions montre honnêtement que les invariants ajoutés apportent interprétabilité et robustesse à la dérive, pas un gain de précision significatif. F2 : sur APTOS en binaire, le modèle hybride CNN-GNN avec géométrie et topologie gagne +7,0 points (95,1 %), plus que la somme des gains individuels, sur un seul découpage. F3 : la structure vasculaire globale est discriminante, confirmée par trois méthodes ; SAMF-GB, un modèle sur CPU, gagne +0,042 de QWK face à EfficientNet-B3 sur GPU. Ce n'est pas une comparaison d'architectures à armes égales, mais cela montre que la structure contient de l'information.</a:t>
+              <a:t>[14:00 – 15:30]  Avant de construire TOPORET, j'ai réuni trois indices, présentés au chapitre 3. F1 : le gabarit de graphe a d'abord été évalué hors de la médecine, sur l'orchestration de microservices et la détection d'anomalies, avec un F1 de 94,4 à 97,0 % dans l'étude de conférence. Mais la réévaluation sur dix exécutions montre honnêtement que les invariants ajoutés apportent de l'interprétabilité et de la robustesse à la dérive, pas un gain de précision significatif. F2 : sur APTOS 2019 en binaire, un modèle hybride CNN-GNN avec géométrie et topologie atteint 95,1 %, soit 7 points de plus que le CNN, sur un seul découpage. F3 : la structure vasculaire globale est discriminante, ce que confirment trois méthodes ; SAMF-GB, un modèle de boosting sur CPU, gagne 0,042 de QWK face à EfficientNet-B3 sur GPU. Ce n'est pas une comparaison d'architectures à armes égales, mais cela justifie de tester un graphe de population qui intègre la topologie.</a:t>
             </a:r>
             <a:endParaRPr lang="en-US" dirty="0"/>
           </a:p>
@@ -2291,7 +2291,7 @@
           <a:p>
             <a:r>
               <a:rPr lang="en-US" dirty="0"/>
-              <a:t>[15:30] Quatrième partie : TOPORET, le cœur des hypothèses H1 et H2.</a:t>
+              <a:t>[15:30 – 15:45]  Quatrième partie : TOPORET, qui porte les hypothèses H1 et H2.</a:t>
             </a:r>
             <a:endParaRPr lang="en-US" dirty="0"/>
           </a:p>
@@ -2379,7 +2379,7 @@
           <a:p>
             <a:r>
               <a:rPr lang="en-US" dirty="0"/>
-              <a:t>[15:45 – 17:15] TOPORET relie les images dans un graphe de population. Deux images sont proches si elles se ressemblent pour le CNN (similarité cosinus) ET si leurs réseaux vasculaires ont une topologie similaire (terme exponentiel sur la distance des descripteurs topologiques). α = 0,6 et τ = 0,65 ont été choisis par grid search sur la validation. La topologie joue un double rôle : dans les arêtes et dans les caractéristiques des nœuds (1 536 dimensions CNN + 6 topologiques = 1 542). Protocole, à dire clairement : validation croisée 5 plis, graine 42, au niveau image, transductive – les images de test sont des nœuds non étiquetés du graphe. À ma connaissance, les descripteurs de persistance du squelette vasculaire n'avaient pas été utilisés dans les arêtes d'un graphe de population.</a:t>
+              <a:t>[15:45 – 17:15]  TOPORET relie les images dans un graphe de population. Deux images sont proches si elles se ressemblent pour le réseau de convolution – c'est la similarité cosinus – et si leurs réseaux vasculaires ont une topologie proche – c'est le terme exponentiel sur la distance entre leurs descripteurs topologiques. Le poids alpha vaut 0,6 et le seuil tau 0,65, choisis par recherche sur grille avec les données de validation. La topologie joue un double rôle : dans les arêtes, et dans les caractéristiques des nœuds, qui concatènent 1 536 dimensions visuelles et 6 dimensions topologiques. Je précise le protocole, tel qu'il est dans le code publié : validation croisée en cinq plis, graine 42, au niveau de l'image, et transductive, c'est-à-dire que les images de test sont présentes dans le graphe comme nœuds non étiquetés.</a:t>
             </a:r>
             <a:endParaRPr lang="en-US" dirty="0"/>
           </a:p>
@@ -2467,7 +2467,7 @@
           <a:p>
             <a:r>
               <a:rPr lang="en-US" dirty="0"/>
-              <a:t>[17:15 – 18:30] Concrètement : on améliore le contraste avec CLAHE, on extrait le squelette des vaisseaux, on prend les points de bifurcation comme nuage de points, puis on calcule la filtration de Vietoris-Rips avec GUDHI. On résume les diagrammes par six nombres : persistance totale, entropie et nombre de composantes longues pour H0, et la même chose pour H1 (les boucles). Une barre est « longue » si elle dépasse 5 % de la plus longue barre. Précision honnête : la similarité compare ces six statistiques, pas les diagrammes complets – c'est un résumé grossier de la topologie.</a:t>
+              <a:t>[17:15 – 18:45]  Concrètement, on améliore le contraste avec CLAHE, on extrait le squelette des vaisseaux, on prend ses points de bifurcation comme nuage de points, puis on calcule une filtration de Vietoris-Rips avec la bibliothèque GUDHI, avec une longueur d'arête maximale de 100 pixels. On résume ensuite les diagrammes par six nombres : pour les composantes H0 comme pour les boucles H1, la persistance totale, l'entropie de persistance et le nombre de barres longues, une barre étant longue si elle dépasse 5 % de la plus longue barre. Je précise honnêtement que la similarité compare ces six statistiques, et non les diagrammes complets : c'est un résumé grossier de la topologie, moins coûteux, qui ne garde que l'information de ces statistiques.</a:t>
             </a:r>
             <a:endParaRPr lang="en-US" dirty="0"/>
           </a:p>
@@ -2555,7 +2555,7 @@
           <a:p>
             <a:r>
               <a:rPr lang="en-US" dirty="0"/>
-              <a:t>[18:30 – 19:30] Sur les trois bases, TOPORET améliore toutes les métriques : +0,04 de QWK sur Kaggle DR, +0,07 sur Messidor-2, +0,04 sur APTOS, et +1,5 à +2,3 points de précision. Le gain est le plus grand sur Messidor-2, dont l'acquisition standardisée donne des squelettes plus propres. Attention : ces chiffres absolus sont obtenus en transductif au niveau image ; ils ne se comparent pas directement aux systèmes publiés. Ce qui est valide, c'est la comparaison appariée avec le même CNN, les mêmes caractéristiques, les mêmes plis.</a:t>
+              <a:t>[18:45 – 20:15]  Sur les trois bases, TOPORET améliore toutes les métriques par rapport au même CNN : le QWK passe de 0,84 à 0,88 sur Kaggle DR, de 0,83 à 0,90 sur Messidor-2, et de 0,82 à 0,86 sur APTOS 2019 ; la précision gagne de 1,5 à 2,3 points. Le gain est le plus grand sur Messidor-2, dont l'acquisition standardisée donne des squelettes plus propres, et le plus faible sur APTOS, dont la qualité d'image est plus variable. Une précaution importante : ces valeurs absolues sont obtenues en transductif, avec des plis au niveau de l'image ; elles ne se comparent pas directement aux systèmes publiés. Ce qui est valide, c'est la comparaison appariée avec le même CNN, sur les mêmes caractéristiques et les mêmes plis.</a:t>
             </a:r>
             <a:endParaRPr lang="en-US" dirty="0"/>
           </a:p>
@@ -2643,7 +2643,7 @@
           <a:p>
             <a:r>
               <a:rPr lang="en-US" dirty="0"/>
-              <a:t>[19:30 – 21:30] Le test pré-spécifié : t-test apparié sur les 5 plis, seuil |t4| &gt; 2,78. Sur Kaggle DR, t4 = 3,82, p = 0,019 : H1 passe, et aussi sur Messidor-2 et APTOS. Mais 5 plis, c'est peu : j'ai ajouté un bootstrap (IC [+0,021 ; +0,059], exclut zéro) et un test de permutation exact (p = 1/32, le minimum possible : le gain est positif dans chaque pli). Et comme les plis partagent leurs données d'entraînement, j'ai appliqué la correction de Nadeau-Bengio : aucune base seule ne reste sous 0,05 (p = 0,070 ; 0,058 ; 0,088), mais les trois bases indépendantes combinées par la méthode de Fisher donnent p = 0,015. Verdict : des preuves convergentes mais limitées en faveur de H1, pas une preuve générale. Je préfère le dire moi-même.</a:t>
+              <a:t>[20:15 – 22:30]  Le test de H1, fixé à l'avance, est un test t apparié sur les cinq plis, avec un seuil de 2,78 en valeur absolue. Sur Kaggle DR, t vaut 3,82, avec p égal à 0,019 : le test est passé, et il l'est aussi sur Messidor-2 et APTOS. Mais cinq plis, c'est peu : quatre degrés de liberté. J'ai donc ajouté deux analyses. Un bootstrap sur les différences donne un intervalle de plus 0,021 à plus 0,059, qui exclut zéro. Un test de permutation exact donne p égal à un trente-deuxième, le minimum possible, car le gain est positif dans chaque pli. Il reste un point : les plis partagent l'essentiel de leurs données d'entraînement. J'ai appliqué la correction de Nadeau et Bengio. Après correction, aucune base seule ne reste sous 0,05 : p vaut 0,070, 0,058 et 0,088. Les trois bases étant indépendantes, je les combine par la méthode de Fisher, ce qui donne p égal à 0,015. Mon verdict est donc le suivant : des preuves convergentes mais limitées en faveur de H1, dans les conditions évaluées, et non une preuve d'un avantage général des graphes de population.</a:t>
             </a:r>
             <a:endParaRPr lang="en-US" dirty="0"/>
           </a:p>
@@ -2731,7 +2731,7 @@
           <a:p>
             <a:r>
               <a:rPr lang="en-US" dirty="0"/>
-              <a:t>[0:45 – 1:15] Le plan suit la logique de la thèse : d'abord le contexte médical expliqué simplement, puis le problème et les hypothèses, les outils utilisés, les premiers résultats, puis les trois systèmes TOPORET, DGTS et DOTS, la partie logicielle, et enfin la synthèse : ce qui est établi, ce qui ne l'est pas, et les perspectives.</a:t>
+              <a:t>[01:00 – 01:45]  La présentation suit la logique de la thèse. Je commence par le contexte médical, que j'expliquerai simplement. Je présente ensuite le problème, les trois hypothèses et la méthodologie, puis les outils utilisés et les premiers résultats qui ont motivé le travail. Viennent ensuite les trois systèmes : TOPORET, puis DGTS et DOTS. Je dirai un mot de la partie logicielle et réglementaire, et je terminerai par une synthèse : ce qui est établi, ce qui ne l'est pas encore, et les perspectives.</a:t>
             </a:r>
             <a:endParaRPr lang="en-US" dirty="0"/>
           </a:p>
@@ -2819,7 +2819,7 @@
           <a:p>
             <a:r>
               <a:rPr lang="en-US" dirty="0"/>
-              <a:t>[21:30 – 22:30] L'ablation sur Kaggle DR isole chaque composant. Les descripteurs topologiques seuls sur les nœuds (B) : +0,02. Le graphe avec des caractéristiques CNN seules, la topologie uniquement dans les arêtes (C) : +0,03, le plus gros contributeur. Le modèle complet (D) : +0,04. Les contributions sont complémentaires et à peu près additives. La matrice de confusion montre que le gain le plus net est à la frontière Légère–Modérée, la plus ambiguë aussi pour les humains. Les tests de l'ablation ne sont pas corrigés du chevauchement des plis – je le signale.</a:t>
+              <a:t>[22:30 – 23:45]  L'ablation sur Kaggle DR isole chaque composant. Ajouter seulement les descripteurs topologiques aux nœuds, sans graphe, donne plus 0,02 de QWK. Le graphe avec des caractéristiques visuelles seules, la topologie n'intervenant que dans les arêtes, donne plus 0,03 : c'est le plus gros contributeur. Le modèle complet donne plus 0,04. Les contributions sont donc complémentaires et à peu près additives. La matrice de confusion montre que l'amélioration la plus nette se situe à la frontière entre les grades léger et modéré, la plus ambiguë aussi pour les experts humains. Je précise que les tests de l'ablation ne sont pas corrigés du chevauchement des plis.</a:t>
             </a:r>
             <a:endParaRPr lang="en-US" dirty="0"/>
           </a:p>
@@ -2907,7 +2907,7 @@
           <a:p>
             <a:r>
               <a:rPr lang="en-US" dirty="0"/>
-              <a:t>[22:30 – 24:00] H2 : une ANOVA pré-spécifiée de la persistance totale H1 sur les cinq grades, sur les 35 126 images de Kaggle DR. F = 84,3, p &lt; 0,001, environ 23 fois la valeur critique. Le seuil de décision 0,005 est inférieur au niveau de Bonferroni pour six descripteurs. Et même si l'échantillon effectif était divisé par deux, F resterait autour de 42. MAIS la taille d'effet est petite : η² ≈ 0,01, le grade explique environ 1 % de la variance. Donc : association statistique robuste, pas une causalité, pas un biomarqueur, pas une signification biologique démontrée. Un lien avec la néovascularisation est plausible mais non vérifié. C'est cohérent avec l'ablation : la topologie est une information complémentaire.</a:t>
+              <a:t>[23:45 – 25:30]  H2 est testée par une analyse de variance fixée à l'avance : la persistance totale H1 est comparée entre les cinq grades, sur les 35 126 images de Kaggle DR. On obtient F égal à 84,3, avec p inférieur à 0,001, soit environ 23 fois la valeur critique. Le seuil de décision, 0,005, est inférieur au niveau de Bonferroni pour six descripteurs. Et comme les deux yeux d'un même patient ne sont pas indépendants, j'ai vérifié que même avec un échantillon effectif divisé par deux, F resterait autour de 42. Mais la taille d'effet est petite : êta carré vaut environ 0,01, c'est-à-dire que le grade explique environ 1 % de la variance. Ma conclusion est donc mesurée : c'est une association statistique robuste, pas une causalité, et pas une signification biologique démontrée. Un lien avec la néovascularisation est plausible, mais non vérifié ; j'emploie le terme de caractéristique topologique associée à la sévérité, et non de biomarqueur. C'est cohérent avec l'ablation : la topologie est une information complémentaire.</a:t>
             </a:r>
             <a:endParaRPr lang="en-US" dirty="0"/>
           </a:p>
@@ -2995,7 +2995,7 @@
           <a:p>
             <a:r>
               <a:rPr lang="en-US" dirty="0"/>
-              <a:t>[24:00 – 25:00] Les limites de TOPORET, que j'expose moi-même. Transductif : les caractéristiques des images de test, pas leurs grades, influencent leurs voisins pendant l'entraînement ; ce n'est pas équivalent à une évaluation strictement inductive et indépendante du patient. Œil adelphe : Kaggle DR et Messidor-2 contiennent les deux yeux, une image test peut être reliée à l'autre œil du même patient. Deux faits limitent ce risque : le gain est aussi observé sur APTOS, une image par patient, et DGTS montre un gain du graphe en mode inductif. La réévaluation au niveau patient est la première perspective : le code publié n'a besoin que d'un découpage groupé.</a:t>
+              <a:t>[25:30 – 27:00]  J'expose moi-même les limites de TOPORET. Validité interne : le protocole est transductif ; les caractéristiques des images de test, mais pas leurs grades, influencent leurs voisins pendant l'entraînement. Ce n'est donc pas équivalent à une évaluation strictement inductive et indépendante du patient. Validité statistique : cinq plis, une graine, et une significativité corrigée seulement pour les trois bases combinées. Validité externe : Kaggle DR et Messidor-2 contiennent les deux yeux de chaque patient ; une image de test peut être reliée à l'œil adelphe du même patient. Deux faits limitent ce risque : le gain est aussi observé sur APTOS, qui n'a qu'une image par patient, et DGTS montre un gain du graphe en mode inductif. La réévaluation au niveau du patient est la première de mes perspectives.</a:t>
             </a:r>
             <a:endParaRPr lang="en-US" dirty="0"/>
           </a:p>
@@ -3083,7 +3083,7 @@
           <a:p>
             <a:r>
               <a:rPr lang="en-US" dirty="0"/>
-              <a:t>[25:00] Cinquième partie : les deux systèmes entraînés sur un corpus multi-source, et le test de H3.</a:t>
+              <a:t>[27:00 – 27:15]  Cinquième partie : les deux systèmes entraînés sur un corpus multi-source, et le test de H3.</a:t>
             </a:r>
             <a:endParaRPr lang="en-US" dirty="0"/>
           </a:p>
@@ -3171,7 +3171,7 @@
           <a:p>
             <a:r>
               <a:rPr lang="en-US" dirty="0"/>
-              <a:t>[25:15 – 26:30] TOPORET laissait trois lacunes : entraînement sur une seule source, perte qui ignore l'ordre, sécurité non mesurée. DGTS et DOTS partagent le même corpus fusionné : APTOS 2019 (3 662 images) + KaggleDR-F1 (2 197) = 5 859 images, 309 sévères et 472 PDR. Ici le découpage image est aussi un découpage patient. Honnêteté sur la provenance : KaggleDR-F1 contient exactement 60 % des effectifs d'APTOS dans chaque grade ; un chevauchement n'est pas exclu, donc la validation croisée est lue comme une preuve interne multi-source, possiblement optimiste. Les conclusions reposent donc sur les évaluations externes : EyePACS pour DGTS (35 126 images, vérifié sans doublon) et Messidor-2 pour DOTS (1 744 images, France).</a:t>
+              <a:t>[27:15 – 28:45]  TOPORET laissait trois lacunes : un entraînement sur une seule source, une perte qui ignore l'ordre des grades, et une sécurité non mesurée. DGTS et DOTS partagent le même corpus fusionné : APTOS 2019, 3 662 images, et KaggleDR-F1, 2 197 images, soit 5 859 images, dont 309 sévères et 472 proliférantes. Pour ce corpus, le découpage par image est aussi un découpage par patient. Un point d'honnêteté sur la provenance : KaggleDR-F1 contient exactement 60 % des effectifs d'APTOS dans chaque grade. Un chevauchement entre les deux sources n'est donc pas exclu, et je lis la validation croisée comme une preuve interne multi-source, peut-être optimiste. C'est pourquoi les conclusions reposent d'abord sur les évaluations externes : EyePACS pour DGTS, 35 126 images, vérifié sans doublon, et Messidor-2 pour DOTS, 1 744 images acquises en France.</a:t>
             </a:r>
             <a:endParaRPr lang="en-US" dirty="0"/>
           </a:p>
@@ -3259,7 +3259,7 @@
           <a:p>
             <a:r>
               <a:rPr lang="en-US" dirty="0"/>
-              <a:t>[26:30 – 28:00] DGTS : EfficientNet-B4 gelé, graphe k-plus-proches-voisins cosinus avec k = 8 construit uniquement sur le pli d'entraînement – donc inductif – et GraphSAGE à deux couches. En parallèle, une branche d'homologie persistante décrit la forme du voisinage de chaque nœud dans l'espace des caractéristiques. Point subtil, souvent demandé : à l'inférence, le descripteur vaut zéro ; la topologie agit comme un régulariseur d'entraînement, via les gradients. Tous les chiffres sont mesurés dans ce réglage. Et ce n'est pas la topologie des vaisseaux. L'ablation (sur APTOS) : le graphe apporte +0,018 de QWK (A2→A3), le régulariseur +0,030 (A2→A4), les deux ensemble +0,052, la fusion +0,011. Wilcoxon DGTS contre CNN : p = 0,031.</a:t>
+              <a:t>[28:45 – 30:15]  DGTS utilise un EfficientNet-B4 gelé, puis construit un graphe des huit plus proches voisins, par similarité cosinus, uniquement sur les images d'entraînement : l'évaluation est donc inductive. Un GraphSAGE à deux couches traite ce graphe. En parallèle, une branche d'homologie persistante décrit la forme du voisinage de chaque nœud dans l'espace des caractéristiques. Un point souvent demandé : à l'inférence, ce descripteur vaut zéro ; la topologie agit comme un régulariseur d'entraînement, à travers les gradients, et tous les chiffres sont mesurés dans ce réglage. Ce n'est pas non plus la topologie des vaisseaux. L'ablation, sur APTOS, montre que le graphe apporte 0,018 de QWK, le régulariseur 0,030, les deux ensemble 0,052, et la fusion des sources 0,011 de plus. Un test de Wilcoxon de DGTS contre le CNN donne p égal à 0,031.</a:t>
             </a:r>
             <a:endParaRPr lang="en-US" dirty="0"/>
           </a:p>
@@ -3347,7 +3347,7 @@
           <a:p>
             <a:r>
               <a:rPr lang="en-US" dirty="0"/>
-              <a:t>[28:00 – 29:00] Appliqué sans réentraînement aux 35 126 images EyePACS, DGTS atteint un QWK de 0,925, soit une baisse de seulement 0,016 par rapport à la validation croisée (0,941). C'est une bonne généralisation. Mais le Sev-NR externe est d'environ 2,1 %, légèrement au-dessus de l'objectif de 2 %. Leçon principale de la thèse : une bonne précision ne garantit pas la sécurité ; il faut les mesurer séparément. C'est ce qui motive DOTS. Côté pratique : 18,3 ms par image sur un GPU T4.</a:t>
+              <a:t>[30:15 – 31:15]  Appliqué sans réentraînement aux 35 126 images d'EyePACS, DGTS atteint un QWK de 0,925, soit une baisse de seulement 0,016 par rapport à la validation croisée. C'est une bonne généralisation. Mais son Sev-NR externe est d'environ 2,1 %, légèrement au-dessus de l'objectif de 2 %. C'est l'une des leçons principales de la thèse : une bonne précision ne garantit pas la sécurité, il faut mesurer les deux séparément. C'est ce qui motive DOTS. DGTS classe une image en 18,3 millisecondes sur un GPU T4.</a:t>
             </a:r>
             <a:endParaRPr lang="en-US" dirty="0"/>
           </a:p>
@@ -3435,7 +3435,7 @@
           <a:p>
             <a:r>
               <a:rPr lang="en-US" dirty="0"/>
-              <a:t>[29:00 – 29:45] Les objectifs de H3, fixés à l'avance : QWK ≥ 0,80, Sev-NR ≤ 2 %, PDR-NR ≤ 2 %, aucune confusion 0↔4. Ils viennent de l'article DOTS et s'inspirent de la pratique du dépistage (essai pivot d'IA autonome, programme national anglais). Ce ne sont pas des seuils réglementaires. Et la définition est volontairement explicite : une image sévère prédite « Modérée » compte comme orientée, ce qui correspond à un parcours où le grade Modéré est déjà orientable ; une définition plus stricte donnerait des taux plus élevés.</a:t>
+              <a:t>[31:15 – 32:15]  Les objectifs de H3 ont été fixés à l'avance : un QWK d'au moins 0,80, un Sev-NR et un PDR-NR d'au plus 2 %, et aucune confusion entre les grades 0 et 4. Ils viennent de l'article DOTS et s'inspirent de la pratique du dépistage : l'essai pivot de l'IA autonome et le programme national anglais. Ce ne sont pas des seuils réglementaires. Et la définition est explicite : une image sévère prédite « modérée » compte comme orientée, ce qui correspond à un parcours où le grade modéré est déjà orientable ; une définition plus stricte donnerait des taux plus élevés.</a:t>
             </a:r>
             <a:endParaRPr lang="en-US" dirty="0"/>
           </a:p>
@@ -3523,7 +3523,7 @@
           <a:p>
             <a:r>
               <a:rPr lang="en-US" dirty="0"/>
-              <a:t>[29:45 – 31:15] DOTS : EfficientNet-B3 fine-tuné, une projection, un encodeur de raffinement (FRE), une tête ordinale CORAL et une augmentation au test (5 transformations). Honnêteté sur le FRE : il a la forme d'un bloc transformer mais opère sur une séquence de longueur un, donc l'attention ne fait rien ; c'est en pratique un MLP résiduel normalisé, et je ne revendique aucun bénéfice de l'attention. L'ablation, avec le même budget de 10 époques : 0,903 → TTA 0,918 → GraphSAGE 0,928 → FRE à la place du graphe 0,937 → CORAL 0,943. Le graphe aide ici aussi (cohérent avec H1), mais le FRE fait mieux à moindre coût. CORAL apporte le plus petit gain de QWK, mais c'est la sécurité qui compte, comme on va le voir.</a:t>
+              <a:t>[32:15 – 33:45]  DOTS utilise un EfficientNet-B3 affiné de bout en bout, une projection, un encodeur de raffinement appelé FRE, une tête ordinale CORAL et une augmentation au test sur cinq transformations. Une remarque honnête sur le FRE : il a la forme d'un bloc transformer, mais il opère sur une séquence de longueur un ; l'attention n'y fait donc rien, et c'est en pratique un perceptron résiduel normalisé. Je ne revendique aucun bénéfice de l'attention. L'ablation, à budget égal de dix époques, montre la progression : 0,903 pour le CNN, 0,918 avec l'augmentation au test, 0,928 avec GraphSAGE, 0,937 avec le FRE à la place du graphe, et 0,943 avec CORAL. Le graphe aide ici aussi, ce qui est cohérent avec H1, mais le FRE fait mieux à moindre coût.</a:t>
             </a:r>
             <a:endParaRPr lang="en-US" dirty="0"/>
           </a:p>
@@ -3611,7 +3611,7 @@
           <a:p>
             <a:r>
               <a:rPr lang="en-US" dirty="0"/>
-              <a:t>[31:15 – 32:45] Résultats de DOTS. En interne, sur 5 859 prédictions hors pli : QWK 0,953, Sev-NR 0,97 % (3 images sur 309), PDR-NR 1,27 % (6 sur 472), aucune confusion 0↔4. Sur Messidor-2, jamais vu à l'entraînement : QWK 0,931, Sev-NR 1,4 %, PDR-NR 1,9 %. Les performances observées satisfont donc tous les objectifs en estimation ponctuelle. Mais – et c'est essentiel – avec 309 images sévères, l'intervalle exact du Sev-NR interne est [0,2 % ; 2,8 %], il dépasse 2 %. La sécurité n'est donc pas démontrée. Il faudrait environ 650 images sévères pour que la borne supérieure passe sous 2 %.</a:t>
+              <a:t>[33:45 – 35:15]  Voici les résultats de DOTS. En interne, sur les 5 859 prédictions hors pli : un QWK de 0,953, un Sev-NR de 0,97 %, soit 3 images sur 309, un PDR-NR de 1,27 %, soit 6 sur 472, et aucune confusion entre 0 et 4. Sur Messidor-2, jamais vu pendant l'entraînement : un QWK de 0,931, un Sev-NR de 1,4 % et un PDR-NR de 1,9 %. Les performances observées satisfont donc tous les objectifs, en estimation ponctuelle. Mais avec 309 images sévères, l'intervalle exact du Sev-NR interne va de 0,2 à 2,8 % : il dépasse 2 %. Et les intervalles externes ne peuvent pas être calculés à partir des effectifs publiés. La sécurité n'est donc pas démontrée. Au taux observé, il faudrait environ 650 images sévères pour que la borne supérieure passe sous 2 %.</a:t>
             </a:r>
             <a:endParaRPr lang="en-US" dirty="0"/>
           </a:p>
@@ -3699,7 +3699,7 @@
           <a:p>
             <a:r>
               <a:rPr lang="en-US" dirty="0"/>
-              <a:t>[1:15] Première partie : le contexte. Je vais l'expliquer simplement, sans prérequis médical.</a:t>
+              <a:t>[01:45 – 02:00]  Première partie : le contexte, et pourquoi le classement de la rétinopathie diabétique est un problème de sécurité, pas seulement de précision.</a:t>
             </a:r>
             <a:endParaRPr lang="en-US" dirty="0"/>
           </a:p>
@@ -3787,7 +3787,7 @@
           <a:p>
             <a:r>
               <a:rPr lang="en-US" dirty="0"/>
-              <a:t>[32:45 – 34:00] H3b sur Messidor-2 : chaque variante réduite échoue sur le Sev-NR : 5,8 % pour le CNN de base, 4,1 % avec GraphSAGE, 3,7 % avec CORAL seul, 2,9 % avec TTA seule. Seule la chaîne complète descend à 1,4 %. Les barres montrent le QWK, les lignes les taux de non-orientation. Enseignement : le composant qui améliore le plus la sécurité n'est pas celui qui améliore le plus le QWK. Limite : la conclusion vaut pour les variantes de cette ablation, pas pour tout système sans l'un de ces composants.</a:t>
+              <a:t>[35:15 – 36:45]  H3b est testée sur Messidor-2. Chaque variante réduite échoue sur le Sev-NR : 5,8 % pour le CNN de base, 4,1 % avec GraphSAGE, 3,7 % avec CORAL seul, 2,9 % avec l'augmentation au test seule. Seule la chaîne complète descend à 1,4 %. Sur la figure, les barres représentent le QWK et les lignes les taux de non-orientation ; toutes les métriques évoluent dans le même sens. L'enseignement est le suivant : le composant qui améliore le plus la sécurité n'est pas celui qui améliore le plus le QWK. La limite : cette conclusion vaut pour les variantes de cette ablation, pas pour tout système auquel il manquerait l'un de ces composants.</a:t>
             </a:r>
             <a:endParaRPr lang="en-US" dirty="0"/>
           </a:p>
@@ -3875,7 +3875,7 @@
           <a:p>
             <a:r>
               <a:rPr lang="en-US" dirty="0"/>
-              <a:t>[34:00 – 34:45] La structure des erreurs compte autant que leur nombre. Sur 597 erreurs, 82,9 % sont entre grades adjacents, aucune ne traverse quatre grades. La confusion dominante est Légère → Modérée, une sur-orientation, pas une sous-orientation. Les images sévères ont une faible précision mais un rappel de 0,770 : DOTS prédit « Sévère » plus souvent qu'il ne faudrait, ce qui est la bonne direction pour l'orientation. Calibration : l'ECE passe de 0,067 à 0,031 par temperature scaling, sans changer le QWK. McNemar DOTS contre CNN : p = 0,013.</a:t>
+              <a:t>[36:45 – 37:45]  La structure des erreurs compte autant que leur nombre. Sur 597 erreurs, 82,9 % sont entre grades adjacents, et aucune ne traverse quatre grades. La confusion dominante est de « léger » vers « modéré » : une sur-orientation, pas une sous-orientation. Les images sévères ont un rappel de 0,770 : DOTS prédit « sévère » plus souvent qu'il ne le faudrait, ce qui est la bonne direction pour l'orientation. Après une mise à l'échelle de température, l'erreur de calibration passe de 0,067 à 0,031, sans changer le QWK. Et le test de McNemar entre DOTS et le CNN donne p égal à 0,013.</a:t>
             </a:r>
             <a:endParaRPr lang="en-US" dirty="0"/>
           </a:p>
@@ -3963,7 +3963,7 @@
           <a:p>
             <a:r>
               <a:rPr lang="en-US" dirty="0"/>
-              <a:t>[34:45] Sixième partie, brièvement : l'ingénierie logicielle.</a:t>
+              <a:t>[37:45 – 38:00]  Sixième partie, brièvement : l'ingénierie logicielle.</a:t>
             </a:r>
             <a:endParaRPr lang="en-US" dirty="0"/>
           </a:p>
@@ -4051,7 +4051,7 @@
           <a:p>
             <a:r>
               <a:rPr lang="en-US" dirty="0"/>
-              <a:t>[35:00 – 36:15] Le chapitre 6 relie l'architecture aux exigences d'IEC 62304 (cycle de vie et vérification unitaire), d'ISO 14971 (gestion des risques, AMDEC sur six dangers) et de l'EU AI Act (système à haut risque, traçabilité, supervision humaine). C'est un exercice d'ingénierie, pas une évaluation de conformité, ni un marquage CE, ni une autorisation FDA. Le tableau d'état le dit clairement : les pipelines sont implémentés en code de recherche et évalués rétrospectivement ; le plan de vérification est spécifié ; l'adaptateur FHIR est conçu mais pas implémenté ; pas de déploiement ni de certification.</a:t>
+              <a:t>[38:00 – 39:15]  Le chapitre 6 relie l'architecture aux exigences de trois référentiels : IEC 62304 pour le cycle de vie du logiciel et la vérification unitaire, ISO 14971 pour la gestion des risques, avec une AMDEC sur six dangers, et l'EU AI Act, qui classe un tel système à haut risque. C'est un exercice d'ingénierie, pas une évaluation de conformité, ni un marquage CE, ni une autorisation de la FDA. Le tableau d'état le montre clairement : les chaînes sont implémentées en code de recherche et évaluées rétrospectivement ; le plan de vérification est spécifié ; l'adaptateur FHIR vers le dossier patient est conçu mais pas implémenté ; il n'y a ni déploiement ni certification.</a:t>
             </a:r>
             <a:endParaRPr lang="en-US" dirty="0"/>
           </a:p>
@@ -4139,7 +4139,7 @@
           <a:p>
             <a:r>
               <a:rPr lang="en-US" dirty="0"/>
-              <a:t>[36:15] Dernière partie : la synthèse.</a:t>
+              <a:t>[39:15 – 39:30]  Dernière partie : la synthèse.</a:t>
             </a:r>
             <a:endParaRPr lang="en-US" dirty="0"/>
           </a:p>
@@ -4227,7 +4227,7 @@
           <a:p>
             <a:r>
               <a:rPr lang="en-US" dirty="0"/>
-              <a:t>[36:30 – 37:15] Cette figure résume l'ensemble : un objectif commun, trois systèmes qui apportent chacun un type de preuve différent – transductive pour TOPORET, inductive et externe pour DGTS, orientée dépistage pour DOTS –, toute cette preuve est rétrospective, et elle s'arrête avant l'évaluation prospective. En bas, en rouge, ce qui n'est pas encore évalué.</a:t>
+              <a:t>[39:30 – 40:30]  Cette figure résume l'ensemble. En haut, l'objectif commun. Au milieu, les trois systèmes, qui apportent chacun un type de preuve différent : une preuve transductive pour TOPORET, une preuve inductive et externe pour DGTS, une preuve orientée dépistage pour DOTS. Toute cette preuve est rétrospective, obtenue sur des données publiques, en interne et sur deux bases externes. Et en bas, en rouge, ce qui n'est pas encore évalué : un modèle unique à trois axes, TOPORET au niveau du patient, plusieurs graines, une étude de lecteurs, des études prospectives et multi-sites, et la validation clinique.</a:t>
             </a:r>
             <a:endParaRPr lang="en-US" dirty="0"/>
           </a:p>
@@ -4315,7 +4315,7 @@
           <a:p>
             <a:r>
               <a:rPr lang="en-US" dirty="0"/>
-              <a:t>[37:15 – 38:30] Je distingue trois niveaux. Montré directement : les quantités mesurées – gain de TOPORET dans chaque pli des trois bases, gains du graphe et du régulariseur dans DGTS, QWK externe de DGTS, estimations ponctuelles de DOTS qui satisfont les objectifs, échec des quatre variantes réduites. Soutenu sans être établi de façon concluante : que l'information relationnelle améliore le grading, que la topologie porte une information liée à la sévérité, que la chaîne ordinale est assez sûre pour le dépistage. Non revendiqué : sécurité clinique, conformité réglementaire, prédiction longitudinale, supériorité générale des graphes.</a:t>
+              <a:t>[40:30 – 42:00]  Je distingue trois niveaux. Ce qui est montré directement, ce sont les quantités mesurées : le gain de TOPORET dans chaque pli des trois bases, les gains du graphe et du régulariseur dans DGTS, le QWK externe de DGTS, les estimations ponctuelles de DOTS qui satisfont les objectifs, et l'échec des quatre variantes réduites. Ce qui est soutenu sans être établi de façon concluante : que l'information relationnelle améliore le classement, que la topologie porte une information liée à la sévérité, et que la chaîne ordinale est assez sûre pour le dépistage. Enfin, ce que la thèse ne revendique pas : la sécurité clinique, la conformité réglementaire, la prédiction longitudinale, ou une supériorité générale des graphes. La contribution centrale est donc un ensemble structuré de preuves rétrospectives sur la façon dont ces trois informations complètent les représentations visuelles profondes.</a:t>
             </a:r>
             <a:endParaRPr lang="en-US" dirty="0"/>
           </a:p>
@@ -4403,7 +4403,7 @@
           <a:p>
             <a:r>
               <a:rPr lang="en-US" dirty="0"/>
-              <a:t>[38:30 – 39:30] Les limites définissent directement les perspectives, dans l'ordre de coût. D'abord réévaluer TOPORET au niveau patient avec un graphe par pli ; puis répéter les expériences sur plusieurs graines ; ajouter de nouvelles bases externes avec assez de cas sévères ; construire un modèle unifié – graphe, topologie vasculaire, tête CORAL – avec un mécanisme d'abstention fondé sur les probabilités calibrées de DOTS ; puis une étude de lecteurs, une étude prospective pré-enregistrée, dimensionnée sur environ 1 240 images sévères pour 80 % de puissance, une vraie validation multi-site ou fédérée, et enfin la validation clinique au sens du règlement sur les dispositifs médicaux.</a:t>
+              <a:t>[42:00 – 43:30]  Les limites définissent directement les perspectives, par ordre de coût. D'abord, réévaluer TOPORET avec un découpage par patient et un graphe construit à chaque pli : le code publié n'a besoin que d'un découpage groupé. Ensuite, répéter les expériences sur plusieurs graines, et ajouter de nouvelles bases externes avec assez de cas sévères, environ 650. Puis construire un modèle unifié – graphe, topologie vasculaire et tête CORAL – avec un mécanisme d'abstention fondé sur les probabilités calibrées de DOTS. Viendraient ensuite une étude de lecteurs, une étude prospective pré-enregistrée, dimensionnée sur environ 1 240 images sévères pour une puissance de 80 %, une vraie validation multi-site ou fédérée, et enfin la validation clinique au sens du règlement européen sur les dispositifs médicaux.</a:t>
             </a:r>
             <a:endParaRPr lang="en-US" dirty="0"/>
           </a:p>
@@ -4491,7 +4491,7 @@
           <a:p>
             <a:r>
               <a:rPr lang="en-US" dirty="0"/>
-              <a:t>[39:30 – 39:45] Treize publications soutiennent la thèse : neuf acceptées ou publiées – sept articles de conférence (ICAART 2025 et 2026, ICPRAM, ENASE, MIUA, IJCNN) et deux chapitres de livre LNAI chez Springer – et quatre articles de revue, dont un en révision à PLOS ONE et trois en cours d'évaluation.</a:t>
+              <a:t>[43:30 – 44:00]  Treize publications soutiennent la thèse : neuf sont acceptées ou publiées – sept articles de conférence, notamment à ICAART, ICPRAM, ENASE, MIUA et IJCNN, et deux chapitres de livre chez Springer – et quatre articles de revue sont soumis, dont un en révision à PLOS ONE et trois en cours d'évaluation.</a:t>
             </a:r>
             <a:endParaRPr lang="en-US" dirty="0"/>
           </a:p>
@@ -4579,7 +4579,7 @@
           <a:p>
             <a:r>
               <a:rPr lang="en-US" dirty="0"/>
-              <a:t>[39:45 – 40:30] Pour conclure, sur les trois axes : R, des preuves en faveur de H1, cohérentes mais limitées par cinq plis, confirmées en inductif avec DGTS. S, une association statistique faible mais robuste, et un régulariseur utile dans DGTS – pas un biomarqueur. O, DOTS satisfait les objectifs de dépistage en estimation ponctuelle, en interne et sur Messidor-2, mais la sécurité n'est pas encore démontrée. Phrase finale, à dire lentement : les informations relationnelles, topologiques et ordinales peuvent compléter les représentations visuelles profondes pour le grading de la rétinopathie diabétique – voici la preuve, et voici exactement où elle s'arrête. Je vous remercie de votre attention, et je suis prêt à répondre à vos questions.</a:t>
+              <a:t>[44:00 – 45:00]  Pour conclure, sur les trois axes. R, les relations : des preuves en faveur de H1, cohérentes mais limitées par cinq plis, et confirmées en mode inductif avec DGTS. S, la topologie : une association statistique faible mais robuste, et un régulariseur utile dans DGTS, sans être un biomarqueur. O, l'ordinalité : DOTS satisfait les objectifs de dépistage en estimation ponctuelle, en interne et sur Messidor-2, mais sa sécurité n'est pas encore démontrée. Les informations relationnelles, topologiques et ordinales peuvent compléter les représentations visuelles profondes pour le classement de la rétinopathie diabétique : voici la preuve, et voici exactement où elle s'arrête. Je vous remercie de votre attention, et je suis prêt à répondre à vos questions.</a:t>
             </a:r>
             <a:endParaRPr lang="en-US" dirty="0"/>
           </a:p>
@@ -4667,7 +4667,7 @@
           <a:p>
             <a:r>
               <a:rPr lang="en-US" dirty="0"/>
-              <a:t>[1:30 – 3:00] Explication simple : le diabète abîme progressivement les petits vaisseaux sanguins, y compris ceux de la rétine, au fond de l'œil. C'est la rétinopathie diabétique. Environ 537 millions d'adultes sont diabétiques, 783 millions attendus en 2045, et environ 103 millions ont une rétinopathie. Le point essentiel : la maladie est silencieuse. Le patient voit bien jusqu'à un stade avancé, alors que le traitement est surtout efficace tôt. D'où la nécessité de dépister chaque diabétique régulièrement, en photographiant le fond d'œil.</a:t>
+              <a:t>[02:00 – 03:15]  Le diabète abîme progressivement les petits vaisseaux sanguins du corps, et en particulier ceux de la rétine, au fond de l'œil. C'est la rétinopathie diabétique. Environ 537 millions d'adultes vivent avec un diabète, et l'on en attend 783 millions en 2045. Environ 103 millions de personnes ont une rétinopathie diabétique, et c'est l'une des premières causes de cécité évitable chez l'adulte en âge de travailler. La difficulté principale est que la maladie est silencieuse : le patient voit normalement jusqu'à un stade avancé, alors que le traitement est surtout efficace tôt. La seule réponse efficace à l'échelle d'une population est donc le dépistage régulier : on photographie le fond d'œil de chaque patient diabétique, et un expert classe l'image. Or le nombre d'images dépasse aujourd'hui largement le nombre d'experts disponibles, surtout là où les ophtalmologistes sont rares. Le classement automatique par apprentissage profond est donc la réponse naturelle.</a:t>
             </a:r>
             <a:endParaRPr lang="en-US" dirty="0"/>
           </a:p>
@@ -4755,7 +4755,7 @@
           <a:p>
             <a:r>
               <a:rPr lang="en-US" dirty="0"/>
-              <a:t>[3:00 – 4:30] Voici les cinq grades de l'échelle internationale ICDR, de 0 (pas de rétinopathie) à 4 (rétinopathie proliférante). Les signes apparaissent dans les vaisseaux : micro-anévrismes, hémorragies, puis, au stade proliférant, de nouveaux vaisseaux anormaux. Ce qui compte pour la sécurité : les grades 3 et 4 doivent être orientés vers l'ophtalmologiste en quelques semaines, voire en urgence. Les grades sont ordonnés : confondre 0 et 4 est bien plus grave que confondre 1 et 2. C'est une idée clé de la thèse.</a:t>
+              <a:t>[03:15 – 04:45]  Voici ce que voit l'expert. L'échelle internationale ICDR compte cinq grades. Le grade 0 : pas de rétinopathie. Le grade 1, légère : seulement des micro-anévrismes, de petites dilatations des capillaires. Le grade 2, modérée : des hémorragies et des exsudats apparaissent. Le grade 3, sévère, défini par la règle dite 4-2-1 : de nombreuses hémorragies dans les quatre quadrants, ou des veines en chapelet, ou des anomalies microvasculaires. Enfin le grade 4, proliférant : de nouveaux vaisseaux anormaux se forment ; c'est une urgence. Deux faits guident toute la thèse. Premièrement, les grades sont ordonnés : confondre un grade 0 avec un grade 4 est beaucoup plus grave que confondre un grade 1 avec un grade 2. Deuxièmement, les grades 3 et 4 doivent être orientés vers l'ophtalmologiste en quelques semaines, voire en urgence. Ce sont donc les erreurs sur ces grades qui comptent le plus pour le patient.</a:t>
             </a:r>
             <a:endParaRPr lang="en-US" dirty="0"/>
           </a:p>
@@ -4843,7 +4843,7 @@
           <a:p>
             <a:r>
               <a:rPr lang="en-US" dirty="0"/>
-              <a:t>[4:30 – 6:00] Un système peut avoir une bonne précision globale et pourtant rater des cas graves. La mesure de sécurité de la thèse est le Sev-NR : la proportion d'images sévères classées « pas de RD » ou « légère », donc non orientées. Exemple illustratif : un programme de 500 000 patients par an, dont environ 25 000 cas sévères. Avec un Sev-NR de 5,8 % – celui d'un CNN de référence sur Messidor-2 dans cette thèse – environ 1 450 cas sévères ne seraient pas orientés chaque année. C'est une projection sous hypothèses, pas un résultat clinique, mais elle montre pourquoi on mesure la sécurité à côté de la précision.</a:t>
+              <a:t>[04:45 – 06:15]  Un système peut avoir une très bonne précision globale et pourtant laisser passer des cas graves. Pour le mesurer, j'utilise le Sev-NR, le taux de non-orientation des cas sévères : la proportion d'images de grade 3 que le système classe « pas de rétinopathie » ou « légère », et qui ne seraient donc pas orientées. Le PDR-NR est la même mesure pour le grade 4. Un exemple illustratif : un programme qui dépiste 500 000 patients par an, dont environ 25 000 ont une forme sévère. Avec un Sev-NR de 5,8 % – c'est la valeur d'un CNN de référence sur la base externe Messidor-2 dans cette thèse –, environ 1 450 cas sévères ne seraient pas orientés chaque année. Je précise que c'est une projection sous hypothèses de prévalence, pas un résultat clinique. Mais elle explique un choix de la thèse : les métriques de sécurité sont toujours rapportées à côté de la précision, et vérifiées sur des données d'un autre pays.</a:t>
             </a:r>
             <a:endParaRPr lang="en-US" dirty="0"/>
           </a:p>
@@ -4931,7 +4931,7 @@
           <a:p>
             <a:r>
               <a:rPr lang="en-US" dirty="0"/>
-              <a:t>[6:00 – 7:30] En étudiant les systèmes représentatifs – Gulshan 2016, CABNet, RETFound – on observe trois limites architecturales. L1 : chaque image est classée seule ; des patients qui se ressemblent ne s'informent jamais. L2 : les réseaux voient la texture locale, mais ne mesurent pas explicitement la structure globale de l'arbre vasculaire, ses composantes et ses boucles. L3 : les grades sont traités comme des catégories sans ordre et le taux de cas sévères non orientés est rarement mesuré. Précision importante : c'est une remarque d'architecture, pas un jugement sur toute la littérature ; plusieurs systèmes ont été validés prospectivement.</a:t>
+              <a:t>[06:15 – 07:45]  En étudiant les systèmes représentatifs de la littérature – par exemple Gulshan et al. en 2016, CABNet en 2021 ou RETFound en 2023 –, on observe trois limites d'architecture. L1 : chaque image est classée isolément ; des patients qui se ressemblent, et qui ont souvent le même grade, ne s'informent jamais. L2 : les réseaux de convolution voient la texture locale, mais ne mesurent pas explicitement la structure globale de l'arbre vasculaire – ses composantes et ses boucles –, qui change avec la maladie. L3 : les grades sont traités comme des catégories sans ordre, et le taux de cas sévères non orientés est rarement mesuré, encore moins sur des données externes. Je souligne que c'est une remarque d'architecture et non un jugement sur toute la littérature : plusieurs systèmes ont été validés prospectivement et déployés.</a:t>
             </a:r>
             <a:endParaRPr lang="en-US" dirty="0"/>
           </a:p>
@@ -5019,7 +5019,7 @@
           <a:p>
             <a:r>
               <a:rPr lang="en-US" dirty="0"/>
-              <a:t>[7:30] Deuxième partie : ce que la thèse cherche à tester, et comment.</a:t>
+              <a:t>[07:45 – 08:00]  Deuxième partie : ce que la thèse cherche à tester, et comment.</a:t>
             </a:r>
             <a:endParaRPr lang="en-US" dirty="0"/>
           </a:p>
@@ -5107,7 +5107,7 @@
           <a:p>
             <a:r>
               <a:rPr lang="en-US" dirty="0"/>
-              <a:t>[7:45 – 9:15] Objectif unique : exploiter les relations, la topologie et l'ordinalité pour améliorer le grading. Trois hypothèses, chacune liée à une limite. H1 : un graphe de population apporte une information au-delà d'un classifieur image par image. H2 : l'homologie persistante du réseau vasculaire est statistiquement associée à la sévérité. H3 : une chaîne ordinale satisfait des objectifs de sécurité fixés à l'avance – QWK ≥ 0,80, Sev-NR et PDR-NR ≤ 2 %, aucune confusion 0↔4 – en interne et sur données externes (H3a), alors qu'aucune de ses variantes réduites n'y parvient (H3b). Point méthodologique important : pour H1 et H2, le test, le seuil et la taille d'effet ont été fixés avant l'expérience.</a:t>
+              <a:t>[08:00 – 09:30]  L'objectif est unique : exploiter les relations, la topologie et l'ordinalité pour améliorer le classement de la rétinopathie diabétique. Il se traduit par trois hypothèses, chacune liée à une limite. H1, l'hypothèse relationnelle : un graphe de population apporte une information au-delà de celle d'un classifieur image par image. H2, l'hypothèse structurelle : l'homologie persistante du réseau vasculaire est statistiquement associée à la sévérité. H3, l'hypothèse de sécurité ordinale : une chaîne ordinale satisfait des objectifs de dépistage fixés à l'avance – un QWK d'au moins 0,80, des taux de non-orientation d'au plus 2 %, et aucune confusion entre les grades 0 et 4 –, en interne et sur des données externes ; c'est H3a. Et aucune de ses variantes réduites n'y parvient ; c'est H3b. Pour H1 et H2, le test, le seuil de décision et la mesure de taille d'effet ont été fixés avant l'expérience, pour qu'un résultat négatif ne puisse pas être expliqué après coup.</a:t>
             </a:r>
             <a:endParaRPr lang="en-US" dirty="0"/>
           </a:p>

</xml_diff>